<commit_message>
Redesign Workplace Ethics slide around a glowing capsule centrepiece
Co-Authored-By: Claude Opus 5.5 <noreply@anthropic.com>
Claude-Session: https://claude.ai/code/session_01TFmXfwWy7YkFL9ETqt4WJz
</commit_message>
<xml_diff>
--- a/Workplace-Ethics-slide.pptx
+++ b/Workplace-Ethics-slide.pptx
@@ -1376,24 +1376,22 @@
       </p:sp>
       <p:pic>
         <p:nvPicPr>
-          <p:cNvPr id="3" name="a1_deco" descr="/tmp/claude-0/-home-user-english-presentaiton-/38e25695-43d6-5158-a0ef-d97df09ff7da/scratchpad/build/assets/hero.png">    </p:cNvPr>
+          <p:cNvPr id="3" name="a1_hero" descr="NutriPill capsule inside glowing rings">    </p:cNvPr>
           <p:cNvPicPr>
             <a:picLocks noChangeAspect="1"/>
           </p:cNvPicPr>
           <p:nvPr/>
         </p:nvPicPr>
         <p:blipFill>
-          <a:blip r:embed="rId1">
-            <a:alphaModFix amt="80000"/>
-          </a:blip>
+          <a:blip r:embed="rId1"/>
           <a:stretch>
             <a:fillRect/>
           </a:stretch>
         </p:blipFill>
         <p:spPr>
           <a:xfrm>
-            <a:off x="-914400" y="4617720"/>
-            <a:ext cx="3566160" cy="3566160"/>
+            <a:off x="4221785" y="2011680"/>
+            <a:ext cx="3749040" cy="3749040"/>
           </a:xfrm>
           <a:prstGeom prst="rect">
             <a:avLst/>
@@ -1402,113 +1400,65 @@
       </p:pic>
       <p:sp>
         <p:nvSpPr>
-          <p:cNvPr id="4" name="a2_k"/>
-          <p:cNvSpPr txBox="1"/>
+          <p:cNvPr id="4" name="a2_glass"/>
+          <p:cNvSpPr/>
           <p:nvPr/>
         </p:nvSpPr>
         <p:spPr>
           <a:xfrm>
-            <a:off x="548640" y="1874520"/>
-            <a:ext cx="4572000" cy="320040"/>
+            <a:off x="548640" y="2011680"/>
+            <a:ext cx="3520440" cy="1783080"/>
           </a:xfrm>
-          <a:prstGeom prst="rect">
-            <a:avLst/>
+          <a:prstGeom prst="roundRect">
+            <a:avLst>
+              <a:gd name="adj" fmla="val 10256"/>
+            </a:avLst>
           </a:prstGeom>
-          <a:noFill/>
-          <a:ln/>
+          <a:solidFill>
+            <a:srgbClr val="FFFFFF">
+              <a:alpha val="9000"/>
+            </a:srgbClr>
+          </a:solidFill>
+          <a:ln w="12700">
+            <a:solidFill>
+              <a:srgbClr val="FFFFFF">
+                <a:alpha val="22000"/>
+              </a:srgbClr>
+            </a:solidFill>
+            <a:prstDash val="solid"/>
+          </a:ln>
         </p:spPr>
-        <p:txBody>
-          <a:bodyPr wrap="square" lIns="0" tIns="0" rIns="0" bIns="0" rtlCol="0" anchor="t"/>
-          <a:lstStyle/>
-          <a:p>
-            <a:pPr indent="0" marL="0">
-              <a:buNone/>
-            </a:pPr>
-            <a:r>
-              <a:rPr lang="en-US" sz="1300" b="1" spc="400" kern="0" dirty="0">
-                <a:solidFill>
-                  <a:srgbClr val="14C9A1"/>
-                </a:solidFill>
-                <a:latin typeface="Calibri" pitchFamily="34" charset="0"/>
-                <a:ea typeface="Calibri" pitchFamily="34" charset="-122"/>
-                <a:cs typeface="Calibri" pitchFamily="34" charset="-120"/>
-              </a:rPr>
-              <a:t>HOW WE WORK</a:t>
-            </a:r>
-            <a:endParaRPr lang="en-US" sz="1300" dirty="0"/>
-          </a:p>
-        </p:txBody>
       </p:sp>
       <p:sp>
         <p:nvSpPr>
-          <p:cNvPr id="5" name="a3_quote"/>
-          <p:cNvSpPr txBox="1"/>
+          <p:cNvPr id="5" name="a2_disc"/>
+          <p:cNvSpPr/>
           <p:nvPr/>
         </p:nvSpPr>
         <p:spPr>
           <a:xfrm>
-            <a:off x="548640" y="2240280"/>
-            <a:ext cx="4663440" cy="1737360"/>
+            <a:off x="822960" y="2286000"/>
+            <a:ext cx="603504" cy="603504"/>
           </a:xfrm>
-          <a:prstGeom prst="rect">
+          <a:prstGeom prst="ellipse">
             <a:avLst/>
           </a:prstGeom>
-          <a:noFill/>
+          <a:solidFill>
+            <a:srgbClr val="14C9A1"/>
+          </a:solidFill>
           <a:ln/>
+          <a:effectLst>
+            <a:outerShdw sx="100000" sy="100000" kx="0" ky="0" algn="bl" rotWithShape="0" blurRad="203200" dist="50800" dir="5400000">
+              <a:srgbClr val="14C9A1">
+                <a:alpha val="60000"/>
+              </a:srgbClr>
+            </a:outerShdw>
+          </a:effectLst>
         </p:spPr>
-        <p:txBody>
-          <a:bodyPr wrap="square" lIns="0" tIns="0" rIns="0" bIns="0" rtlCol="0" anchor="t"/>
-          <a:lstStyle/>
-          <a:p>
-            <a:pPr indent="0" marL="0">
-              <a:buNone/>
-            </a:pPr>
-            <a:r>
-              <a:rPr lang="en-US" sz="3000" b="1" dirty="0">
-                <a:solidFill>
-                  <a:srgbClr val="FFFFFF"/>
-                </a:solidFill>
-                <a:latin typeface="Calibri" pitchFamily="34" charset="0"/>
-                <a:ea typeface="Calibri" pitchFamily="34" charset="-122"/>
-                <a:cs typeface="Calibri" pitchFamily="34" charset="-120"/>
-              </a:rPr>
-              <a:t>At NutriPill, how we treat people </a:t>
-            </a:r>
-            <a:pPr indent="0" marL="0">
-              <a:buNone/>
-            </a:pPr>
-            <a:r>
-              <a:rPr lang="en-US" sz="3000" b="1" dirty="0">
-                <a:solidFill>
-                  <a:srgbClr val="14C9A1"/>
-                </a:solidFill>
-                <a:latin typeface="Calibri" pitchFamily="34" charset="0"/>
-                <a:ea typeface="Calibri" pitchFamily="34" charset="-122"/>
-                <a:cs typeface="Calibri" pitchFamily="34" charset="-120"/>
-              </a:rPr>
-              <a:t>matters as much as</a:t>
-            </a:r>
-            <a:pPr indent="0" marL="0">
-              <a:buNone/>
-            </a:pPr>
-            <a:r>
-              <a:rPr lang="en-US" sz="3000" b="1" dirty="0">
-                <a:solidFill>
-                  <a:srgbClr val="FFFFFF"/>
-                </a:solidFill>
-                <a:latin typeface="Calibri" pitchFamily="34" charset="0"/>
-                <a:ea typeface="Calibri" pitchFamily="34" charset="-122"/>
-                <a:cs typeface="Calibri" pitchFamily="34" charset="-120"/>
-              </a:rPr>
-              <a:t> what we sell.</a:t>
-            </a:r>
-            <a:endParaRPr lang="en-US" sz="3000" dirty="0"/>
-          </a:p>
-        </p:txBody>
       </p:sp>
       <p:pic>
         <p:nvPicPr>
-          <p:cNvPr id="6" name="a4_mark" descr="NutriPill logo">    </p:cNvPr>
+          <p:cNvPr id="6" name="a2_icon" descr="Respect for everyone">    </p:cNvPr>
           <p:cNvPicPr>
             <a:picLocks noChangeAspect="1"/>
           </p:cNvPicPr>
@@ -1522,8 +1472,8 @@
         </p:blipFill>
         <p:spPr>
           <a:xfrm>
-            <a:off x="502920" y="4160520"/>
-            <a:ext cx="640080" cy="640080"/>
+            <a:off x="969264" y="2432304"/>
+            <a:ext cx="310896" cy="310896"/>
           </a:xfrm>
           <a:prstGeom prst="rect">
             <a:avLst/>
@@ -1532,14 +1482,14 @@
       </p:pic>
       <p:sp>
         <p:nvSpPr>
-          <p:cNvPr id="7" name="a4_sig"/>
+          <p:cNvPr id="7" name="a2_h"/>
           <p:cNvSpPr txBox="1"/>
           <p:nvPr/>
         </p:nvSpPr>
         <p:spPr>
           <a:xfrm>
-            <a:off x="1280160" y="4160520"/>
-            <a:ext cx="3200400" cy="640080"/>
+            <a:off x="1572768" y="2249424"/>
+            <a:ext cx="2331720" cy="676656"/>
           </a:xfrm>
           <a:prstGeom prst="rect">
             <a:avLst/>
@@ -1555,7 +1505,24 @@
               <a:buNone/>
             </a:pPr>
             <a:r>
-              <a:rPr lang="en-US" sz="1500" b="1" dirty="0">
+              <a:rPr lang="en-US" sz="1200" b="1" spc="200" kern="0" dirty="0">
+                <a:solidFill>
+                  <a:srgbClr val="14C9A1"/>
+                </a:solidFill>
+                <a:latin typeface="Calibri" pitchFamily="34" charset="0"/>
+                <a:ea typeface="Calibri" pitchFamily="34" charset="-122"/>
+                <a:cs typeface="Calibri" pitchFamily="34" charset="-120"/>
+              </a:rPr>
+              <a:t>01</a:t>
+            </a:r>
+            <a:endParaRPr lang="en-US" sz="1200" dirty="0"/>
+          </a:p>
+          <a:p>
+            <a:pPr indent="0" marL="0">
+              <a:buNone/>
+            </a:pPr>
+            <a:r>
+              <a:rPr lang="en-US" sz="1700" b="1" dirty="0">
                 <a:solidFill>
                   <a:srgbClr val="FFFFFF"/>
                 </a:solidFill>
@@ -1563,198 +1530,22 @@
                 <a:ea typeface="Calibri" pitchFamily="34" charset="-122"/>
                 <a:cs typeface="Calibri" pitchFamily="34" charset="-120"/>
               </a:rPr>
-              <a:t>William</a:t>
+              <a:t>Respect for everyone</a:t>
             </a:r>
-            <a:endParaRPr lang="en-US" sz="1500" dirty="0"/>
-          </a:p>
-          <a:p>
-            <a:pPr indent="0" marL="0">
-              <a:buNone/>
-            </a:pPr>
-            <a:r>
-              <a:rPr lang="en-US" sz="1500" dirty="0">
-                <a:solidFill>
-                  <a:srgbClr val="B8C7D9"/>
-                </a:solidFill>
-                <a:latin typeface="Calibri" pitchFamily="34" charset="0"/>
-                <a:ea typeface="Calibri" pitchFamily="34" charset="-122"/>
-                <a:cs typeface="Calibri" pitchFamily="34" charset="-120"/>
-              </a:rPr>
-              <a:t>HR Manager, NutriPill</a:t>
-            </a:r>
-            <a:endParaRPr lang="en-US" sz="1500" dirty="0"/>
+            <a:endParaRPr lang="en-US" sz="1200" dirty="0"/>
           </a:p>
         </p:txBody>
       </p:sp>
       <p:sp>
         <p:nvSpPr>
-          <p:cNvPr id="8" name="a5_body"/>
-          <p:cNvSpPr/>
-          <p:nvPr/>
-        </p:nvSpPr>
-        <p:spPr>
-          <a:xfrm>
-            <a:off x="5623560" y="1874520"/>
-            <a:ext cx="5897880" cy="1097280"/>
-          </a:xfrm>
-          <a:prstGeom prst="roundRect">
-            <a:avLst>
-              <a:gd name="adj" fmla="val 50000"/>
-            </a:avLst>
-          </a:prstGeom>
-          <a:solidFill>
-            <a:srgbClr val="FFFFFF"/>
-          </a:solidFill>
-          <a:ln/>
-          <a:effectLst>
-            <a:outerShdw sx="100000" sy="100000" kx="0" ky="0" algn="bl" rotWithShape="0" blurRad="228600" dist="76200" dir="5400000">
-              <a:srgbClr val="000000">
-                <a:alpha val="30000"/>
-              </a:srgbClr>
-            </a:outerShdw>
-          </a:effectLst>
-        </p:spPr>
-      </p:sp>
-      <p:sp>
-        <p:nvSpPr>
-          <p:cNvPr id="9" name="a5_half"/>
-          <p:cNvSpPr/>
-          <p:nvPr/>
-        </p:nvSpPr>
-        <p:spPr>
-          <a:xfrm>
-            <a:off x="5623560" y="1874520"/>
-            <a:ext cx="1554480" cy="1097280"/>
-          </a:xfrm>
-          <a:prstGeom prst="roundRect">
-            <a:avLst>
-              <a:gd name="adj" fmla="val 50000"/>
-            </a:avLst>
-          </a:prstGeom>
-          <a:solidFill>
-            <a:srgbClr val="14C9A1"/>
-          </a:solidFill>
-          <a:ln/>
-        </p:spPr>
-      </p:sp>
-      <p:sp>
-        <p:nvSpPr>
-          <p:cNvPr id="10" name="a5_halfsq"/>
-          <p:cNvSpPr/>
-          <p:nvPr/>
-        </p:nvSpPr>
-        <p:spPr>
-          <a:xfrm>
-            <a:off x="6629400" y="1874520"/>
-            <a:ext cx="548640" cy="1097280"/>
-          </a:xfrm>
-          <a:prstGeom prst="rect">
-            <a:avLst/>
-          </a:prstGeom>
-          <a:solidFill>
-            <a:srgbClr val="14C9A1"/>
-          </a:solidFill>
-          <a:ln/>
-        </p:spPr>
-      </p:sp>
-      <p:sp>
-        <p:nvSpPr>
-          <p:cNvPr id="11" name="a5_seam"/>
-          <p:cNvSpPr/>
-          <p:nvPr/>
-        </p:nvSpPr>
-        <p:spPr>
-          <a:xfrm>
-            <a:off x="7178040" y="1874520"/>
-            <a:ext cx="0" cy="1097280"/>
-          </a:xfrm>
-          <a:prstGeom prst="line">
-            <a:avLst/>
-          </a:prstGeom>
-          <a:noFill/>
-          <a:ln w="12700">
-            <a:solidFill>
-              <a:srgbClr val="0B1F3A">
-                <a:alpha val="15000"/>
-              </a:srgbClr>
-            </a:solidFill>
-            <a:prstDash val="solid"/>
-          </a:ln>
-        </p:spPr>
-      </p:sp>
-      <p:pic>
-        <p:nvPicPr>
-          <p:cNvPr id="12" name="a5_icon" descr="Respect for everyone">    </p:cNvPr>
-          <p:cNvPicPr>
-            <a:picLocks noChangeAspect="1"/>
-          </p:cNvPicPr>
-          <p:nvPr/>
-        </p:nvPicPr>
-        <p:blipFill>
-          <a:blip r:embed="rId3"/>
-          <a:stretch>
-            <a:fillRect/>
-          </a:stretch>
-        </p:blipFill>
-        <p:spPr>
-          <a:xfrm>
-            <a:off x="6190488" y="2203704"/>
-            <a:ext cx="438912" cy="438912"/>
-          </a:xfrm>
-          <a:prstGeom prst="rect">
-            <a:avLst/>
-          </a:prstGeom>
-        </p:spPr>
-      </p:pic>
-      <p:sp>
-        <p:nvSpPr>
-          <p:cNvPr id="13" name="a5_h"/>
+          <p:cNvPr id="8" name="a2_d"/>
           <p:cNvSpPr txBox="1"/>
           <p:nvPr/>
         </p:nvSpPr>
         <p:spPr>
           <a:xfrm>
-            <a:off x="7406640" y="2002536"/>
-            <a:ext cx="3886200" cy="365760"/>
-          </a:xfrm>
-          <a:prstGeom prst="rect">
-            <a:avLst/>
-          </a:prstGeom>
-          <a:noFill/>
-          <a:ln/>
-        </p:spPr>
-        <p:txBody>
-          <a:bodyPr wrap="square" lIns="0" tIns="0" rIns="0" bIns="0" rtlCol="0" anchor="t"/>
-          <a:lstStyle/>
-          <a:p>
-            <a:pPr indent="0" marL="0">
-              <a:buNone/>
-            </a:pPr>
-            <a:r>
-              <a:rPr lang="en-US" sz="1900" b="1" dirty="0">
-                <a:solidFill>
-                  <a:srgbClr val="0B1F3A"/>
-                </a:solidFill>
-                <a:latin typeface="Calibri" pitchFamily="34" charset="0"/>
-                <a:ea typeface="Calibri" pitchFamily="34" charset="-122"/>
-                <a:cs typeface="Calibri" pitchFamily="34" charset="-120"/>
-              </a:rPr>
-              <a:t>Respect for everyone</a:t>
-            </a:r>
-            <a:endParaRPr lang="en-US" sz="1900" dirty="0"/>
-          </a:p>
-        </p:txBody>
-      </p:sp>
-      <p:sp>
-        <p:nvSpPr>
-          <p:cNvPr id="14" name="a5_d"/>
-          <p:cNvSpPr txBox="1"/>
-          <p:nvPr/>
-        </p:nvSpPr>
-        <p:spPr>
-          <a:xfrm>
-            <a:off x="7406640" y="2368296"/>
-            <a:ext cx="3886200" cy="502920"/>
+            <a:off x="822960" y="3017520"/>
+            <a:ext cx="3017520" cy="685800"/>
           </a:xfrm>
           <a:prstGeom prst="rect">
             <a:avLst/>
@@ -1772,7 +1563,7 @@
             <a:r>
               <a:rPr lang="en-US" sz="1400" dirty="0">
                 <a:solidFill>
-                  <a:srgbClr val="5B6B80"/>
+                  <a:srgbClr val="B8C7D9"/>
                 </a:solidFill>
                 <a:latin typeface="Calibri" pitchFamily="34" charset="0"/>
                 <a:ea typeface="Calibri" pitchFamily="34" charset="-122"/>
@@ -1786,118 +1577,128 @@
       </p:sp>
       <p:sp>
         <p:nvSpPr>
-          <p:cNvPr id="15" name="a6_body"/>
+          <p:cNvPr id="9" name="a2_line"/>
           <p:cNvSpPr/>
           <p:nvPr/>
         </p:nvSpPr>
         <p:spPr>
           <a:xfrm>
-            <a:off x="5623560" y="3200400"/>
-            <a:ext cx="5897880" cy="1097280"/>
+            <a:off x="4069080" y="2903220"/>
+            <a:ext cx="740055" cy="0"/>
           </a:xfrm>
-          <a:prstGeom prst="roundRect">
-            <a:avLst>
-              <a:gd name="adj" fmla="val 50000"/>
-            </a:avLst>
+          <a:prstGeom prst="line">
+            <a:avLst/>
           </a:prstGeom>
-          <a:solidFill>
-            <a:srgbClr val="FFFFFF"/>
-          </a:solidFill>
-          <a:ln/>
-          <a:effectLst>
-            <a:outerShdw sx="100000" sy="100000" kx="0" ky="0" algn="bl" rotWithShape="0" blurRad="228600" dist="76200" dir="5400000">
-              <a:srgbClr val="000000">
-                <a:alpha val="30000"/>
-              </a:srgbClr>
-            </a:outerShdw>
-          </a:effectLst>
+          <a:noFill/>
+          <a:ln w="19050">
+            <a:solidFill>
+              <a:srgbClr val="14C9A1"/>
+            </a:solidFill>
+            <a:prstDash val="dash"/>
+          </a:ln>
         </p:spPr>
       </p:sp>
       <p:sp>
         <p:nvSpPr>
-          <p:cNvPr id="16" name="a6_half"/>
+          <p:cNvPr id="10" name="a2_node"/>
           <p:cNvSpPr/>
           <p:nvPr/>
         </p:nvSpPr>
         <p:spPr>
           <a:xfrm>
-            <a:off x="5623560" y="3200400"/>
-            <a:ext cx="1554480" cy="1097280"/>
+            <a:off x="4726839" y="2820924"/>
+            <a:ext cx="164592" cy="164592"/>
           </a:xfrm>
-          <a:prstGeom prst="roundRect">
-            <a:avLst>
-              <a:gd name="adj" fmla="val 50000"/>
-            </a:avLst>
+          <a:prstGeom prst="ellipse">
+            <a:avLst/>
           </a:prstGeom>
           <a:solidFill>
-            <a:srgbClr val="2E9E5B"/>
+            <a:srgbClr val="14C9A1"/>
           </a:solidFill>
-          <a:ln/>
+          <a:ln w="19050">
+            <a:solidFill>
+              <a:srgbClr val="FFFFFF"/>
+            </a:solidFill>
+            <a:prstDash val="solid"/>
+          </a:ln>
         </p:spPr>
       </p:sp>
       <p:sp>
         <p:nvSpPr>
-          <p:cNvPr id="17" name="a6_halfsq"/>
+          <p:cNvPr id="11" name="a3_glass"/>
           <p:cNvSpPr/>
           <p:nvPr/>
         </p:nvSpPr>
         <p:spPr>
           <a:xfrm>
-            <a:off x="6629400" y="3200400"/>
-            <a:ext cx="548640" cy="1097280"/>
+            <a:off x="548640" y="3977640"/>
+            <a:ext cx="3520440" cy="1783080"/>
           </a:xfrm>
-          <a:prstGeom prst="rect">
+          <a:prstGeom prst="roundRect">
+            <a:avLst>
+              <a:gd name="adj" fmla="val 10256"/>
+            </a:avLst>
+          </a:prstGeom>
+          <a:solidFill>
+            <a:srgbClr val="FFFFFF">
+              <a:alpha val="9000"/>
+            </a:srgbClr>
+          </a:solidFill>
+          <a:ln w="12700">
+            <a:solidFill>
+              <a:srgbClr val="FFFFFF">
+                <a:alpha val="22000"/>
+              </a:srgbClr>
+            </a:solidFill>
+            <a:prstDash val="solid"/>
+          </a:ln>
+        </p:spPr>
+      </p:sp>
+      <p:sp>
+        <p:nvSpPr>
+          <p:cNvPr id="12" name="a3_disc"/>
+          <p:cNvSpPr/>
+          <p:nvPr/>
+        </p:nvSpPr>
+        <p:spPr>
+          <a:xfrm>
+            <a:off x="822960" y="4251960"/>
+            <a:ext cx="603504" cy="603504"/>
+          </a:xfrm>
+          <a:prstGeom prst="ellipse">
             <a:avLst/>
           </a:prstGeom>
           <a:solidFill>
             <a:srgbClr val="2E9E5B"/>
           </a:solidFill>
           <a:ln/>
-        </p:spPr>
-      </p:sp>
-      <p:sp>
-        <p:nvSpPr>
-          <p:cNvPr id="18" name="a6_seam"/>
-          <p:cNvSpPr/>
-          <p:nvPr/>
-        </p:nvSpPr>
-        <p:spPr>
-          <a:xfrm>
-            <a:off x="7178040" y="3200400"/>
-            <a:ext cx="0" cy="1097280"/>
-          </a:xfrm>
-          <a:prstGeom prst="line">
-            <a:avLst/>
-          </a:prstGeom>
-          <a:noFill/>
-          <a:ln w="12700">
-            <a:solidFill>
-              <a:srgbClr val="0B1F3A">
-                <a:alpha val="15000"/>
+          <a:effectLst>
+            <a:outerShdw sx="100000" sy="100000" kx="0" ky="0" algn="bl" rotWithShape="0" blurRad="203200" dist="50800" dir="5400000">
+              <a:srgbClr val="2E9E5B">
+                <a:alpha val="60000"/>
               </a:srgbClr>
-            </a:solidFill>
-            <a:prstDash val="solid"/>
-          </a:ln>
+            </a:outerShdw>
+          </a:effectLst>
         </p:spPr>
       </p:sp>
       <p:pic>
         <p:nvPicPr>
-          <p:cNvPr id="19" name="a6_icon" descr="Living our values">    </p:cNvPr>
+          <p:cNvPr id="13" name="a3_icon" descr="Living our values">    </p:cNvPr>
           <p:cNvPicPr>
             <a:picLocks noChangeAspect="1"/>
           </p:cNvPicPr>
           <p:nvPr/>
         </p:nvPicPr>
         <p:blipFill>
-          <a:blip r:embed="rId4"/>
+          <a:blip r:embed="rId3"/>
           <a:stretch>
             <a:fillRect/>
           </a:stretch>
         </p:blipFill>
         <p:spPr>
           <a:xfrm>
-            <a:off x="6190488" y="3529584"/>
-            <a:ext cx="438912" cy="438912"/>
+            <a:off x="969264" y="4398264"/>
+            <a:ext cx="310896" cy="310896"/>
           </a:xfrm>
           <a:prstGeom prst="rect">
             <a:avLst/>
@@ -1906,14 +1707,14 @@
       </p:pic>
       <p:sp>
         <p:nvSpPr>
-          <p:cNvPr id="20" name="a6_h"/>
+          <p:cNvPr id="14" name="a3_h"/>
           <p:cNvSpPr txBox="1"/>
           <p:nvPr/>
         </p:nvSpPr>
         <p:spPr>
           <a:xfrm>
-            <a:off x="7406640" y="3328416"/>
-            <a:ext cx="3886200" cy="365760"/>
+            <a:off x="1572768" y="4215384"/>
+            <a:ext cx="2331720" cy="676656"/>
           </a:xfrm>
           <a:prstGeom prst="rect">
             <a:avLst/>
@@ -1922,16 +1723,33 @@
           <a:ln/>
         </p:spPr>
         <p:txBody>
-          <a:bodyPr wrap="square" lIns="0" tIns="0" rIns="0" bIns="0" rtlCol="0" anchor="t"/>
+          <a:bodyPr wrap="square" lIns="0" tIns="0" rIns="0" bIns="0" rtlCol="0" anchor="ctr"/>
           <a:lstStyle/>
           <a:p>
             <a:pPr indent="0" marL="0">
               <a:buNone/>
             </a:pPr>
             <a:r>
-              <a:rPr lang="en-US" sz="1900" b="1" dirty="0">
+              <a:rPr lang="en-US" sz="1200" b="1" spc="200" kern="0" dirty="0">
                 <a:solidFill>
-                  <a:srgbClr val="0B1F3A"/>
+                  <a:srgbClr val="2E9E5B"/>
+                </a:solidFill>
+                <a:latin typeface="Calibri" pitchFamily="34" charset="0"/>
+                <a:ea typeface="Calibri" pitchFamily="34" charset="-122"/>
+                <a:cs typeface="Calibri" pitchFamily="34" charset="-120"/>
+              </a:rPr>
+              <a:t>02</a:t>
+            </a:r>
+            <a:endParaRPr lang="en-US" sz="1200" dirty="0"/>
+          </a:p>
+          <a:p>
+            <a:pPr indent="0" marL="0">
+              <a:buNone/>
+            </a:pPr>
+            <a:r>
+              <a:rPr lang="en-US" sz="1700" b="1" dirty="0">
+                <a:solidFill>
+                  <a:srgbClr val="FFFFFF"/>
                 </a:solidFill>
                 <a:latin typeface="Calibri" pitchFamily="34" charset="0"/>
                 <a:ea typeface="Calibri" pitchFamily="34" charset="-122"/>
@@ -1939,20 +1757,20 @@
               </a:rPr>
               <a:t>Living our values</a:t>
             </a:r>
-            <a:endParaRPr lang="en-US" sz="1900" dirty="0"/>
+            <a:endParaRPr lang="en-US" sz="1200" dirty="0"/>
           </a:p>
         </p:txBody>
       </p:sp>
       <p:sp>
         <p:nvSpPr>
-          <p:cNvPr id="21" name="a6_d"/>
+          <p:cNvPr id="15" name="a3_d"/>
           <p:cNvSpPr txBox="1"/>
           <p:nvPr/>
         </p:nvSpPr>
         <p:spPr>
           <a:xfrm>
-            <a:off x="7406640" y="3694176"/>
-            <a:ext cx="3886200" cy="502920"/>
+            <a:off x="822960" y="4983480"/>
+            <a:ext cx="3017520" cy="685800"/>
           </a:xfrm>
           <a:prstGeom prst="rect">
             <a:avLst/>
@@ -1970,7 +1788,7 @@
             <a:r>
               <a:rPr lang="en-US" sz="1400" dirty="0">
                 <a:solidFill>
-                  <a:srgbClr val="5B6B80"/>
+                  <a:srgbClr val="B8C7D9"/>
                 </a:solidFill>
                 <a:latin typeface="Calibri" pitchFamily="34" charset="0"/>
                 <a:ea typeface="Calibri" pitchFamily="34" charset="-122"/>
@@ -1984,118 +1802,128 @@
       </p:sp>
       <p:sp>
         <p:nvSpPr>
-          <p:cNvPr id="22" name="a7_body"/>
+          <p:cNvPr id="16" name="a3_line"/>
           <p:cNvSpPr/>
           <p:nvPr/>
         </p:nvSpPr>
         <p:spPr>
           <a:xfrm>
-            <a:off x="5623560" y="4526280"/>
-            <a:ext cx="5897880" cy="1097280"/>
+            <a:off x="4069080" y="4869180"/>
+            <a:ext cx="740055" cy="0"/>
           </a:xfrm>
-          <a:prstGeom prst="roundRect">
-            <a:avLst>
-              <a:gd name="adj" fmla="val 50000"/>
-            </a:avLst>
+          <a:prstGeom prst="line">
+            <a:avLst/>
           </a:prstGeom>
-          <a:solidFill>
-            <a:srgbClr val="FFFFFF"/>
-          </a:solidFill>
-          <a:ln/>
-          <a:effectLst>
-            <a:outerShdw sx="100000" sy="100000" kx="0" ky="0" algn="bl" rotWithShape="0" blurRad="228600" dist="76200" dir="5400000">
-              <a:srgbClr val="000000">
-                <a:alpha val="30000"/>
-              </a:srgbClr>
-            </a:outerShdw>
-          </a:effectLst>
+          <a:noFill/>
+          <a:ln w="19050">
+            <a:solidFill>
+              <a:srgbClr val="2E9E5B"/>
+            </a:solidFill>
+            <a:prstDash val="dash"/>
+          </a:ln>
         </p:spPr>
       </p:sp>
       <p:sp>
         <p:nvSpPr>
-          <p:cNvPr id="23" name="a7_half"/>
+          <p:cNvPr id="17" name="a3_node"/>
           <p:cNvSpPr/>
           <p:nvPr/>
         </p:nvSpPr>
         <p:spPr>
           <a:xfrm>
-            <a:off x="5623560" y="4526280"/>
-            <a:ext cx="1554480" cy="1097280"/>
+            <a:off x="4726839" y="4786884"/>
+            <a:ext cx="164592" cy="164592"/>
           </a:xfrm>
-          <a:prstGeom prst="roundRect">
-            <a:avLst>
-              <a:gd name="adj" fmla="val 50000"/>
-            </a:avLst>
+          <a:prstGeom prst="ellipse">
+            <a:avLst/>
           </a:prstGeom>
           <a:solidFill>
-            <a:srgbClr val="FF6B4A"/>
+            <a:srgbClr val="2E9E5B"/>
           </a:solidFill>
-          <a:ln/>
+          <a:ln w="19050">
+            <a:solidFill>
+              <a:srgbClr val="FFFFFF"/>
+            </a:solidFill>
+            <a:prstDash val="solid"/>
+          </a:ln>
         </p:spPr>
       </p:sp>
       <p:sp>
         <p:nvSpPr>
-          <p:cNvPr id="24" name="a7_halfsq"/>
+          <p:cNvPr id="18" name="a4_glass"/>
           <p:cNvSpPr/>
           <p:nvPr/>
         </p:nvSpPr>
         <p:spPr>
           <a:xfrm>
-            <a:off x="6629400" y="4526280"/>
-            <a:ext cx="548640" cy="1097280"/>
+            <a:off x="8122615" y="2011680"/>
+            <a:ext cx="3520440" cy="1783080"/>
           </a:xfrm>
-          <a:prstGeom prst="rect">
+          <a:prstGeom prst="roundRect">
+            <a:avLst>
+              <a:gd name="adj" fmla="val 10256"/>
+            </a:avLst>
+          </a:prstGeom>
+          <a:solidFill>
+            <a:srgbClr val="FFFFFF">
+              <a:alpha val="9000"/>
+            </a:srgbClr>
+          </a:solidFill>
+          <a:ln w="12700">
+            <a:solidFill>
+              <a:srgbClr val="FFFFFF">
+                <a:alpha val="22000"/>
+              </a:srgbClr>
+            </a:solidFill>
+            <a:prstDash val="solid"/>
+          </a:ln>
+        </p:spPr>
+      </p:sp>
+      <p:sp>
+        <p:nvSpPr>
+          <p:cNvPr id="19" name="a4_disc"/>
+          <p:cNvSpPr/>
+          <p:nvPr/>
+        </p:nvSpPr>
+        <p:spPr>
+          <a:xfrm>
+            <a:off x="8396935" y="2286000"/>
+            <a:ext cx="603504" cy="603504"/>
+          </a:xfrm>
+          <a:prstGeom prst="ellipse">
             <a:avLst/>
           </a:prstGeom>
           <a:solidFill>
             <a:srgbClr val="FF6B4A"/>
           </a:solidFill>
           <a:ln/>
-        </p:spPr>
-      </p:sp>
-      <p:sp>
-        <p:nvSpPr>
-          <p:cNvPr id="25" name="a7_seam"/>
-          <p:cNvSpPr/>
-          <p:nvPr/>
-        </p:nvSpPr>
-        <p:spPr>
-          <a:xfrm>
-            <a:off x="7178040" y="4526280"/>
-            <a:ext cx="0" cy="1097280"/>
-          </a:xfrm>
-          <a:prstGeom prst="line">
-            <a:avLst/>
-          </a:prstGeom>
-          <a:noFill/>
-          <a:ln w="12700">
-            <a:solidFill>
-              <a:srgbClr val="0B1F3A">
-                <a:alpha val="15000"/>
+          <a:effectLst>
+            <a:outerShdw sx="100000" sy="100000" kx="0" ky="0" algn="bl" rotWithShape="0" blurRad="203200" dist="50800" dir="5400000">
+              <a:srgbClr val="FF6B4A">
+                <a:alpha val="60000"/>
               </a:srgbClr>
-            </a:solidFill>
-            <a:prstDash val="solid"/>
-          </a:ln>
+            </a:outerShdw>
+          </a:effectLst>
         </p:spPr>
       </p:sp>
       <p:pic>
         <p:nvPicPr>
-          <p:cNvPr id="26" name="a7_icon" descr="Prices for every pocket">    </p:cNvPr>
+          <p:cNvPr id="20" name="a4_icon" descr="Fair prices for all">    </p:cNvPr>
           <p:cNvPicPr>
             <a:picLocks noChangeAspect="1"/>
           </p:cNvPicPr>
           <p:nvPr/>
         </p:nvPicPr>
         <p:blipFill>
-          <a:blip r:embed="rId5"/>
+          <a:blip r:embed="rId4"/>
           <a:stretch>
             <a:fillRect/>
           </a:stretch>
         </p:blipFill>
         <p:spPr>
           <a:xfrm>
-            <a:off x="6190488" y="4855464"/>
-            <a:ext cx="438912" cy="438912"/>
+            <a:off x="8543239" y="2432304"/>
+            <a:ext cx="310896" cy="310896"/>
           </a:xfrm>
           <a:prstGeom prst="rect">
             <a:avLst/>
@@ -2104,14 +1932,14 @@
       </p:pic>
       <p:sp>
         <p:nvSpPr>
-          <p:cNvPr id="27" name="a7_h"/>
+          <p:cNvPr id="21" name="a4_h"/>
           <p:cNvSpPr txBox="1"/>
           <p:nvPr/>
         </p:nvSpPr>
         <p:spPr>
           <a:xfrm>
-            <a:off x="7406640" y="4654296"/>
-            <a:ext cx="3886200" cy="365760"/>
+            <a:off x="9146743" y="2249424"/>
+            <a:ext cx="2331720" cy="676656"/>
           </a:xfrm>
           <a:prstGeom prst="rect">
             <a:avLst/>
@@ -2120,37 +1948,54 @@
           <a:ln/>
         </p:spPr>
         <p:txBody>
-          <a:bodyPr wrap="square" lIns="0" tIns="0" rIns="0" bIns="0" rtlCol="0" anchor="t"/>
+          <a:bodyPr wrap="square" lIns="0" tIns="0" rIns="0" bIns="0" rtlCol="0" anchor="ctr"/>
           <a:lstStyle/>
           <a:p>
             <a:pPr indent="0" marL="0">
               <a:buNone/>
             </a:pPr>
             <a:r>
-              <a:rPr lang="en-US" sz="1900" b="1" dirty="0">
+              <a:rPr lang="en-US" sz="1200" b="1" spc="200" kern="0" dirty="0">
                 <a:solidFill>
-                  <a:srgbClr val="0B1F3A"/>
+                  <a:srgbClr val="FF6B4A"/>
                 </a:solidFill>
                 <a:latin typeface="Calibri" pitchFamily="34" charset="0"/>
                 <a:ea typeface="Calibri" pitchFamily="34" charset="-122"/>
                 <a:cs typeface="Calibri" pitchFamily="34" charset="-120"/>
               </a:rPr>
-              <a:t>Prices for every pocket</a:t>
+              <a:t>03</a:t>
             </a:r>
-            <a:endParaRPr lang="en-US" sz="1900" dirty="0"/>
+            <a:endParaRPr lang="en-US" sz="1200" dirty="0"/>
+          </a:p>
+          <a:p>
+            <a:pPr indent="0" marL="0">
+              <a:buNone/>
+            </a:pPr>
+            <a:r>
+              <a:rPr lang="en-US" sz="1700" b="1" dirty="0">
+                <a:solidFill>
+                  <a:srgbClr val="FFFFFF"/>
+                </a:solidFill>
+                <a:latin typeface="Calibri" pitchFamily="34" charset="0"/>
+                <a:ea typeface="Calibri" pitchFamily="34" charset="-122"/>
+                <a:cs typeface="Calibri" pitchFamily="34" charset="-120"/>
+              </a:rPr>
+              <a:t>Fair prices for all</a:t>
+            </a:r>
+            <a:endParaRPr lang="en-US" sz="1200" dirty="0"/>
           </a:p>
         </p:txBody>
       </p:sp>
       <p:sp>
         <p:nvSpPr>
-          <p:cNvPr id="28" name="a7_d"/>
+          <p:cNvPr id="22" name="a4_d"/>
           <p:cNvSpPr txBox="1"/>
           <p:nvPr/>
         </p:nvSpPr>
         <p:spPr>
           <a:xfrm>
-            <a:off x="7406640" y="5020056"/>
-            <a:ext cx="3886200" cy="502920"/>
+            <a:off x="8396935" y="3017520"/>
+            <a:ext cx="3017520" cy="685800"/>
           </a:xfrm>
           <a:prstGeom prst="rect">
             <a:avLst/>
@@ -2168,7 +2013,7 @@
             <a:r>
               <a:rPr lang="en-US" sz="1400" dirty="0">
                 <a:solidFill>
-                  <a:srgbClr val="5B6B80"/>
+                  <a:srgbClr val="B8C7D9"/>
                 </a:solidFill>
                 <a:latin typeface="Calibri" pitchFamily="34" charset="0"/>
                 <a:ea typeface="Calibri" pitchFamily="34" charset="-122"/>
@@ -2182,36 +2027,147 @@
       </p:sp>
       <p:sp>
         <p:nvSpPr>
-          <p:cNvPr id="29" name="a8_chip"/>
+          <p:cNvPr id="23" name="a4_line"/>
           <p:cNvSpPr/>
           <p:nvPr/>
         </p:nvSpPr>
         <p:spPr>
           <a:xfrm>
-            <a:off x="5623560" y="5897880"/>
-            <a:ext cx="5897880" cy="502920"/>
+            <a:off x="7383475" y="2903220"/>
+            <a:ext cx="739140" cy="0"/>
           </a:xfrm>
-          <a:prstGeom prst="roundRect">
-            <a:avLst>
-              <a:gd name="adj" fmla="val 49091"/>
-            </a:avLst>
+          <a:prstGeom prst="line">
+            <a:avLst/>
+          </a:prstGeom>
+          <a:noFill/>
+          <a:ln w="19050">
+            <a:solidFill>
+              <a:srgbClr val="FF6B4A"/>
+            </a:solidFill>
+            <a:prstDash val="dash"/>
+          </a:ln>
+        </p:spPr>
+      </p:sp>
+      <p:sp>
+        <p:nvSpPr>
+          <p:cNvPr id="24" name="a4_node"/>
+          <p:cNvSpPr/>
+          <p:nvPr/>
+        </p:nvSpPr>
+        <p:spPr>
+          <a:xfrm>
+            <a:off x="8040319" y="2820924"/>
+            <a:ext cx="164592" cy="164592"/>
+          </a:xfrm>
+          <a:prstGeom prst="ellipse">
+            <a:avLst/>
           </a:prstGeom>
           <a:solidFill>
-            <a:srgbClr val="14C9A1">
-              <a:alpha val="15000"/>
-            </a:srgbClr>
+            <a:srgbClr val="FF6B4A"/>
           </a:solidFill>
-          <a:ln w="15875">
+          <a:ln w="19050">
             <a:solidFill>
-              <a:srgbClr val="14C9A1"/>
+              <a:srgbClr val="FFFFFF"/>
             </a:solidFill>
             <a:prstDash val="solid"/>
           </a:ln>
         </p:spPr>
       </p:sp>
+      <p:sp>
+        <p:nvSpPr>
+          <p:cNvPr id="25" name="a5_card"/>
+          <p:cNvSpPr/>
+          <p:nvPr/>
+        </p:nvSpPr>
+        <p:spPr>
+          <a:xfrm>
+            <a:off x="8122615" y="3977640"/>
+            <a:ext cx="3520440" cy="1783080"/>
+          </a:xfrm>
+          <a:prstGeom prst="roundRect">
+            <a:avLst>
+              <a:gd name="adj" fmla="val 10256"/>
+            </a:avLst>
+          </a:prstGeom>
+          <a:solidFill>
+            <a:srgbClr val="14C9A1"/>
+          </a:solidFill>
+          <a:ln/>
+          <a:effectLst>
+            <a:outerShdw sx="100000" sy="100000" kx="0" ky="0" algn="bl" rotWithShape="0" blurRad="304800" dist="50800" dir="5400000">
+              <a:srgbClr val="14C9A1">
+                <a:alpha val="45000"/>
+              </a:srgbClr>
+            </a:outerShdw>
+          </a:effectLst>
+        </p:spPr>
+      </p:sp>
       <p:pic>
         <p:nvPicPr>
-          <p:cNvPr id="30" name="a8_lock" descr="lock">    </p:cNvPr>
+          <p:cNvPr id="26" name="a5_q" descr="/tmp/claude-0/-home-user-english-presentaiton-/38e25695-43d6-5158-a0ef-d97df09ff7da/scratchpad/build/assets/ic-quote-navy.png">    </p:cNvPr>
+          <p:cNvPicPr>
+            <a:picLocks noChangeAspect="1"/>
+          </p:cNvPicPr>
+          <p:nvPr/>
+        </p:nvPicPr>
+        <p:blipFill>
+          <a:blip r:embed="rId5"/>
+          <a:stretch>
+            <a:fillRect/>
+          </a:stretch>
+        </p:blipFill>
+        <p:spPr>
+          <a:xfrm>
+            <a:off x="8396935" y="4206240"/>
+            <a:ext cx="347472" cy="347472"/>
+          </a:xfrm>
+          <a:prstGeom prst="rect">
+            <a:avLst/>
+          </a:prstGeom>
+        </p:spPr>
+      </p:pic>
+      <p:sp>
+        <p:nvSpPr>
+          <p:cNvPr id="27" name="a5_t"/>
+          <p:cNvSpPr txBox="1"/>
+          <p:nvPr/>
+        </p:nvSpPr>
+        <p:spPr>
+          <a:xfrm>
+            <a:off x="8396935" y="4599432"/>
+            <a:ext cx="3017520" cy="685800"/>
+          </a:xfrm>
+          <a:prstGeom prst="rect">
+            <a:avLst/>
+          </a:prstGeom>
+          <a:noFill/>
+          <a:ln/>
+        </p:spPr>
+        <p:txBody>
+          <a:bodyPr wrap="square" lIns="0" tIns="0" rIns="0" bIns="0" rtlCol="0" anchor="t"/>
+          <a:lstStyle/>
+          <a:p>
+            <a:pPr indent="0" marL="0">
+              <a:buNone/>
+            </a:pPr>
+            <a:r>
+              <a:rPr lang="en-US" sz="1700" b="1" dirty="0">
+                <a:solidFill>
+                  <a:srgbClr val="0B1F3A"/>
+                </a:solidFill>
+                <a:latin typeface="Calibri" pitchFamily="34" charset="0"/>
+                <a:ea typeface="Calibri" pitchFamily="34" charset="-122"/>
+                <a:cs typeface="Calibri" pitchFamily="34" charset="-120"/>
+              </a:rPr>
+              <a:t>How we treat people matters as much as what we sell.</a:t>
+            </a:r>
+            <a:endParaRPr lang="en-US" sz="1700" dirty="0"/>
+          </a:p>
+        </p:txBody>
+      </p:sp>
+      <p:pic>
+        <p:nvPicPr>
+          <p:cNvPr id="28" name="a5_mark" descr="NutriPill logo">    </p:cNvPr>
           <p:cNvPicPr>
             <a:picLocks noChangeAspect="1"/>
           </p:cNvPicPr>
@@ -2225,8 +2181,8 @@
         </p:blipFill>
         <p:spPr>
           <a:xfrm>
-            <a:off x="5852160" y="6016752"/>
-            <a:ext cx="265176" cy="265176"/>
+            <a:off x="8342071" y="5257800"/>
+            <a:ext cx="411480" cy="411480"/>
           </a:xfrm>
           <a:prstGeom prst="rect">
             <a:avLst/>
@@ -2235,14 +2191,14 @@
       </p:pic>
       <p:sp>
         <p:nvSpPr>
-          <p:cNvPr id="31" name="a8_t"/>
+          <p:cNvPr id="29" name="a5_sig"/>
           <p:cNvSpPr txBox="1"/>
           <p:nvPr/>
         </p:nvSpPr>
         <p:spPr>
           <a:xfrm>
-            <a:off x="6263640" y="5897880"/>
-            <a:ext cx="5120640" cy="502920"/>
+            <a:off x="8808415" y="5285232"/>
+            <a:ext cx="2377440" cy="365760"/>
           </a:xfrm>
           <a:prstGeom prst="rect">
             <a:avLst/>
@@ -2258,7 +2214,159 @@
               <a:buNone/>
             </a:pPr>
             <a:r>
-              <a:rPr lang="en-US" sz="1500" dirty="0">
+              <a:rPr lang="en-US" sz="1400" b="1" dirty="0">
+                <a:solidFill>
+                  <a:srgbClr val="0B1F3A"/>
+                </a:solidFill>
+                <a:latin typeface="Calibri" pitchFamily="34" charset="0"/>
+                <a:ea typeface="Calibri" pitchFamily="34" charset="-122"/>
+                <a:cs typeface="Calibri" pitchFamily="34" charset="-120"/>
+              </a:rPr>
+              <a:t>William</a:t>
+            </a:r>
+            <a:pPr indent="0" marL="0">
+              <a:buNone/>
+            </a:pPr>
+            <a:r>
+              <a:rPr lang="en-US" sz="1400" dirty="0">
+                <a:solidFill>
+                  <a:srgbClr val="0B1F3A"/>
+                </a:solidFill>
+                <a:latin typeface="Calibri" pitchFamily="34" charset="0"/>
+                <a:ea typeface="Calibri" pitchFamily="34" charset="-122"/>
+                <a:cs typeface="Calibri" pitchFamily="34" charset="-120"/>
+              </a:rPr>
+              <a:t>  ·  HR Manager</a:t>
+            </a:r>
+            <a:endParaRPr lang="en-US" sz="1400" dirty="0"/>
+          </a:p>
+        </p:txBody>
+      </p:sp>
+      <p:sp>
+        <p:nvSpPr>
+          <p:cNvPr id="30" name="a5_line"/>
+          <p:cNvSpPr/>
+          <p:nvPr/>
+        </p:nvSpPr>
+        <p:spPr>
+          <a:xfrm>
+            <a:off x="7383475" y="4869180"/>
+            <a:ext cx="739140" cy="0"/>
+          </a:xfrm>
+          <a:prstGeom prst="line">
+            <a:avLst/>
+          </a:prstGeom>
+          <a:noFill/>
+          <a:ln w="19050">
+            <a:solidFill>
+              <a:srgbClr val="14C9A1"/>
+            </a:solidFill>
+            <a:prstDash val="dash"/>
+          </a:ln>
+        </p:spPr>
+      </p:sp>
+      <p:sp>
+        <p:nvSpPr>
+          <p:cNvPr id="31" name="a5_node"/>
+          <p:cNvSpPr/>
+          <p:nvPr/>
+        </p:nvSpPr>
+        <p:spPr>
+          <a:xfrm>
+            <a:off x="8040319" y="4786884"/>
+            <a:ext cx="164592" cy="164592"/>
+          </a:xfrm>
+          <a:prstGeom prst="ellipse">
+            <a:avLst/>
+          </a:prstGeom>
+          <a:solidFill>
+            <a:srgbClr val="14C9A1"/>
+          </a:solidFill>
+          <a:ln w="19050">
+            <a:solidFill>
+              <a:srgbClr val="FFFFFF"/>
+            </a:solidFill>
+            <a:prstDash val="solid"/>
+          </a:ln>
+        </p:spPr>
+      </p:sp>
+      <p:sp>
+        <p:nvSpPr>
+          <p:cNvPr id="32" name="a6_chip"/>
+          <p:cNvSpPr/>
+          <p:nvPr/>
+        </p:nvSpPr>
+        <p:spPr>
+          <a:xfrm>
+            <a:off x="3124505" y="6053328"/>
+            <a:ext cx="5943600" cy="457200"/>
+          </a:xfrm>
+          <a:prstGeom prst="roundRect">
+            <a:avLst>
+              <a:gd name="adj" fmla="val 50000"/>
+            </a:avLst>
+          </a:prstGeom>
+          <a:solidFill>
+            <a:srgbClr val="0B1F3A"/>
+          </a:solidFill>
+          <a:ln w="15875">
+            <a:solidFill>
+              <a:srgbClr val="14C9A1"/>
+            </a:solidFill>
+            <a:prstDash val="solid"/>
+          </a:ln>
+        </p:spPr>
+      </p:sp>
+      <p:pic>
+        <p:nvPicPr>
+          <p:cNvPr id="33" name="a6_lock" descr="lock">    </p:cNvPr>
+          <p:cNvPicPr>
+            <a:picLocks noChangeAspect="1"/>
+          </p:cNvPicPr>
+          <p:nvPr/>
+        </p:nvPicPr>
+        <p:blipFill>
+          <a:blip r:embed="rId7"/>
+          <a:stretch>
+            <a:fillRect/>
+          </a:stretch>
+        </p:blipFill>
+        <p:spPr>
+          <a:xfrm>
+            <a:off x="3325673" y="6163056"/>
+            <a:ext cx="237744" cy="237744"/>
+          </a:xfrm>
+          <a:prstGeom prst="rect">
+            <a:avLst/>
+          </a:prstGeom>
+        </p:spPr>
+      </p:pic>
+      <p:sp>
+        <p:nvSpPr>
+          <p:cNvPr id="34" name="a6_t"/>
+          <p:cNvSpPr txBox="1"/>
+          <p:nvPr/>
+        </p:nvSpPr>
+        <p:spPr>
+          <a:xfrm>
+            <a:off x="3673145" y="6053328"/>
+            <a:ext cx="5257800" cy="457200"/>
+          </a:xfrm>
+          <a:prstGeom prst="rect">
+            <a:avLst/>
+          </a:prstGeom>
+          <a:noFill/>
+          <a:ln/>
+        </p:spPr>
+        <p:txBody>
+          <a:bodyPr wrap="square" lIns="0" tIns="0" rIns="0" bIns="0" rtlCol="0" anchor="ctr"/>
+          <a:lstStyle/>
+          <a:p>
+            <a:pPr indent="0" marL="0">
+              <a:buNone/>
+            </a:pPr>
+            <a:r>
+              <a:rPr lang="en-US" sz="1400" dirty="0">
                 <a:solidFill>
                   <a:srgbClr val="FFFFFF"/>
                 </a:solidFill>
@@ -2272,7 +2380,7 @@
               <a:buNone/>
             </a:pPr>
             <a:r>
-              <a:rPr lang="en-US" sz="1500" b="1" dirty="0">
+              <a:rPr lang="en-US" sz="1400" b="1" dirty="0">
                 <a:solidFill>
                   <a:srgbClr val="14C9A1"/>
                 </a:solidFill>
@@ -2286,7 +2394,7 @@
               <a:buNone/>
             </a:pPr>
             <a:r>
-              <a:rPr lang="en-US" sz="1500" i="1" dirty="0">
+              <a:rPr lang="en-US" sz="1400" i="1" dirty="0">
                 <a:solidFill>
                   <a:srgbClr val="FFFFFF"/>
                 </a:solidFill>
@@ -2294,15 +2402,15 @@
                 <a:ea typeface="Calibri" pitchFamily="34" charset="-122"/>
                 <a:cs typeface="Calibri" pitchFamily="34" charset="-120"/>
               </a:rPr>
-              <a:t>: 1 pill a day keeps the hunger away!</a:t>
+              <a:t>  ·  1 pill a day keeps the hunger away!</a:t>
             </a:r>
-            <a:endParaRPr lang="en-US" sz="1500" dirty="0"/>
+            <a:endParaRPr lang="en-US" sz="1400" dirty="0"/>
           </a:p>
         </p:txBody>
       </p:sp>
       <p:sp>
         <p:nvSpPr>
-          <p:cNvPr id="33" name="Text 0"/>
+          <p:cNvPr id="36" name="Text 0"/>
           <p:cNvSpPr/>
           <p:nvPr>
             <p:ph idx="101" type="body" hasCustomPrompt="1"/>
@@ -2392,7 +2500,7 @@
               <p:cTn id="2" dur="indefinite" nodeType="mainSeq">
                 <p:childTnLst>
                   <p:par>
-                    <p:cTn id="158" fill="hold">
+                    <p:cTn id="173" fill="hold">
                       <p:stCondLst>
                         <p:cond delay="indefinite"/>
                         <p:cond evt="onBegin" delay="0">
@@ -2487,7 +2595,7 @@
                                           </p:stCondLst>
                                         </p:cTn>
                                         <p:tgtEl>
-                                          <p:spTgt spid="33"/>
+                                          <p:spTgt spid="36"/>
                                         </p:tgtEl>
                                         <p:attrNameLst>
                                           <p:attrName>style.visibility</p:attrName>
@@ -2501,7 +2609,7 @@
                                       <p:cBhvr>
                                         <p:cTn id="11" dur="600"/>
                                         <p:tgtEl>
-                                          <p:spTgt spid="33"/>
+                                          <p:spTgt spid="36"/>
                                         </p:tgtEl>
                                       </p:cBhvr>
                                     </p:animEffect>
@@ -2509,7 +2617,7 @@
                                       <p:cBhvr>
                                         <p:cTn id="12" dur="600" decel="100000" fill="hold"/>
                                         <p:tgtEl>
-                                          <p:spTgt spid="33"/>
+                                          <p:spTgt spid="36"/>
                                         </p:tgtEl>
                                         <p:attrNameLst>
                                           <p:attrName>ppt_y</p:attrName>
@@ -2675,7 +2783,7 @@
                             </p:stCondLst>
                             <p:childTnLst>
                               <p:par>
-                                <p:cTn id="24" presetID="42" presetClass="entr" presetSubtype="0" fill="hold" grpId="0" nodeType="afterEffect">
+                                <p:cTn id="24" presetID="42" presetClass="entr" presetSubtype="0" fill="hold" grpId="0" nodeType="withEffect">
                                   <p:stCondLst>
                                     <p:cond delay="0"/>
                                   </p:stCondLst>
@@ -2742,7 +2850,7 @@
                             </p:stCondLst>
                             <p:childTnLst>
                               <p:par>
-                                <p:cTn id="29" presetID="42" presetClass="entr" presetSubtype="0" fill="hold" grpId="0" nodeType="afterEffect">
+                                <p:cTn id="29" presetID="42" presetClass="entr" presetSubtype="0" fill="hold" grpId="0" nodeType="withEffect">
                                   <p:stCondLst>
                                     <p:cond delay="0"/>
                                   </p:stCondLst>
@@ -2876,7 +2984,7 @@
                             </p:stCondLst>
                             <p:childTnLst>
                               <p:par>
-                                <p:cTn id="39" presetID="42" presetClass="entr" presetSubtype="0" fill="hold" grpId="0" nodeType="afterEffect">
+                                <p:cTn id="39" presetID="42" presetClass="entr" presetSubtype="0" fill="hold" grpId="0" nodeType="withEffect">
                                   <p:stCondLst>
                                     <p:cond delay="0"/>
                                   </p:stCondLst>
@@ -3077,7 +3185,7 @@
                             </p:stCondLst>
                             <p:childTnLst>
                               <p:par>
-                                <p:cTn id="54" presetID="42" presetClass="entr" presetSubtype="0" fill="hold" grpId="0" nodeType="withEffect">
+                                <p:cTn id="54" presetID="42" presetClass="entr" presetSubtype="0" fill="hold" grpId="0" nodeType="afterEffect">
                                   <p:stCondLst>
                                     <p:cond delay="0"/>
                                   </p:stCondLst>
@@ -3345,7 +3453,7 @@
                             </p:stCondLst>
                             <p:childTnLst>
                               <p:par>
-                                <p:cTn id="74" presetID="42" presetClass="entr" presetSubtype="0" fill="hold" grpId="0" nodeType="afterEffect">
+                                <p:cTn id="74" presetID="42" presetClass="entr" presetSubtype="0" fill="hold" grpId="0" nodeType="withEffect">
                                   <p:stCondLst>
                                     <p:cond delay="0"/>
                                   </p:stCondLst>
@@ -3546,7 +3654,7 @@
                             </p:stCondLst>
                             <p:childTnLst>
                               <p:par>
-                                <p:cTn id="89" presetID="42" presetClass="entr" presetSubtype="0" fill="hold" grpId="0" nodeType="withEffect">
+                                <p:cTn id="89" presetID="42" presetClass="entr" presetSubtype="0" fill="hold" grpId="0" nodeType="afterEffect">
                                   <p:stCondLst>
                                     <p:cond delay="0"/>
                                   </p:stCondLst>
@@ -3814,7 +3922,7 @@
                             </p:stCondLst>
                             <p:childTnLst>
                               <p:par>
-                                <p:cTn id="109" presetID="42" presetClass="entr" presetSubtype="0" fill="hold" grpId="0" nodeType="afterEffect">
+                                <p:cTn id="109" presetID="42" presetClass="entr" presetSubtype="0" fill="hold" grpId="0" nodeType="withEffect">
                                   <p:stCondLst>
                                     <p:cond delay="0"/>
                                   </p:stCondLst>
@@ -4015,7 +4123,7 @@
                             </p:stCondLst>
                             <p:childTnLst>
                               <p:par>
-                                <p:cTn id="124" presetID="42" presetClass="entr" presetSubtype="0" fill="hold" grpId="0" nodeType="withEffect">
+                                <p:cTn id="124" presetID="42" presetClass="entr" presetSubtype="0" fill="hold" grpId="0" nodeType="afterEffect">
                                   <p:stCondLst>
                                     <p:cond delay="0"/>
                                   </p:stCondLst>
@@ -4283,7 +4391,7 @@
                             </p:stCondLst>
                             <p:childTnLst>
                               <p:par>
-                                <p:cTn id="144" presetID="42" presetClass="entr" presetSubtype="0" fill="hold" grpId="0" nodeType="afterEffect">
+                                <p:cTn id="144" presetID="42" presetClass="entr" presetSubtype="0" fill="hold" grpId="0" nodeType="withEffect">
                                   <p:stCondLst>
                                     <p:cond delay="0"/>
                                   </p:stCondLst>
@@ -4453,6 +4561,207 @@
                                         <p:cTn id="157" dur="600" decel="100000" fill="hold"/>
                                         <p:tgtEl>
                                           <p:spTgt spid="31"/>
+                                        </p:tgtEl>
+                                        <p:attrNameLst>
+                                          <p:attrName>ppt_y</p:attrName>
+                                        </p:attrNameLst>
+                                      </p:cBhvr>
+                                      <p:tavLst>
+                                        <p:tav tm="0">
+                                          <p:val>
+                                            <p:strVal val="#ppt_y+0.04"/>
+                                          </p:val>
+                                        </p:tav>
+                                        <p:tav tm="100000">
+                                          <p:val>
+                                            <p:strVal val="#ppt_y"/>
+                                          </p:val>
+                                        </p:tav>
+                                      </p:tavLst>
+                                    </p:anim>
+                                  </p:childTnLst>
+                                </p:cTn>
+                              </p:par>
+                            </p:childTnLst>
+                          </p:cTn>
+                        </p:par>
+                        <p:par>
+                          <p:cTn id="158" fill="hold">
+                            <p:stCondLst>
+                              <p:cond delay="0"/>
+                            </p:stCondLst>
+                            <p:childTnLst>
+                              <p:par>
+                                <p:cTn id="159" presetID="42" presetClass="entr" presetSubtype="0" fill="hold" grpId="0" nodeType="afterEffect">
+                                  <p:stCondLst>
+                                    <p:cond delay="0"/>
+                                  </p:stCondLst>
+                                  <p:childTnLst>
+                                    <p:set>
+                                      <p:cBhvr>
+                                        <p:cTn id="160" dur="1" fill="hold">
+                                          <p:stCondLst>
+                                            <p:cond delay="0"/>
+                                          </p:stCondLst>
+                                        </p:cTn>
+                                        <p:tgtEl>
+                                          <p:spTgt spid="32"/>
+                                        </p:tgtEl>
+                                        <p:attrNameLst>
+                                          <p:attrName>style.visibility</p:attrName>
+                                        </p:attrNameLst>
+                                      </p:cBhvr>
+                                      <p:to>
+                                        <p:strVal val="visible"/>
+                                      </p:to>
+                                    </p:set>
+                                    <p:animEffect transition="in" filter="fade">
+                                      <p:cBhvr>
+                                        <p:cTn id="161" dur="600"/>
+                                        <p:tgtEl>
+                                          <p:spTgt spid="32"/>
+                                        </p:tgtEl>
+                                      </p:cBhvr>
+                                    </p:animEffect>
+                                    <p:anim calcmode="lin" valueType="num">
+                                      <p:cBhvr>
+                                        <p:cTn id="162" dur="600" decel="100000" fill="hold"/>
+                                        <p:tgtEl>
+                                          <p:spTgt spid="32"/>
+                                        </p:tgtEl>
+                                        <p:attrNameLst>
+                                          <p:attrName>ppt_y</p:attrName>
+                                        </p:attrNameLst>
+                                      </p:cBhvr>
+                                      <p:tavLst>
+                                        <p:tav tm="0">
+                                          <p:val>
+                                            <p:strVal val="#ppt_y+0.04"/>
+                                          </p:val>
+                                        </p:tav>
+                                        <p:tav tm="100000">
+                                          <p:val>
+                                            <p:strVal val="#ppt_y"/>
+                                          </p:val>
+                                        </p:tav>
+                                      </p:tavLst>
+                                    </p:anim>
+                                  </p:childTnLst>
+                                </p:cTn>
+                              </p:par>
+                            </p:childTnLst>
+                          </p:cTn>
+                        </p:par>
+                        <p:par>
+                          <p:cTn id="163" fill="hold">
+                            <p:stCondLst>
+                              <p:cond delay="0"/>
+                            </p:stCondLst>
+                            <p:childTnLst>
+                              <p:par>
+                                <p:cTn id="164" presetID="42" presetClass="entr" presetSubtype="0" fill="hold" grpId="0" nodeType="withEffect">
+                                  <p:stCondLst>
+                                    <p:cond delay="0"/>
+                                  </p:stCondLst>
+                                  <p:childTnLst>
+                                    <p:set>
+                                      <p:cBhvr>
+                                        <p:cTn id="165" dur="1" fill="hold">
+                                          <p:stCondLst>
+                                            <p:cond delay="0"/>
+                                          </p:stCondLst>
+                                        </p:cTn>
+                                        <p:tgtEl>
+                                          <p:spTgt spid="33"/>
+                                        </p:tgtEl>
+                                        <p:attrNameLst>
+                                          <p:attrName>style.visibility</p:attrName>
+                                        </p:attrNameLst>
+                                      </p:cBhvr>
+                                      <p:to>
+                                        <p:strVal val="visible"/>
+                                      </p:to>
+                                    </p:set>
+                                    <p:animEffect transition="in" filter="fade">
+                                      <p:cBhvr>
+                                        <p:cTn id="166" dur="600"/>
+                                        <p:tgtEl>
+                                          <p:spTgt spid="33"/>
+                                        </p:tgtEl>
+                                      </p:cBhvr>
+                                    </p:animEffect>
+                                    <p:anim calcmode="lin" valueType="num">
+                                      <p:cBhvr>
+                                        <p:cTn id="167" dur="600" decel="100000" fill="hold"/>
+                                        <p:tgtEl>
+                                          <p:spTgt spid="33"/>
+                                        </p:tgtEl>
+                                        <p:attrNameLst>
+                                          <p:attrName>ppt_y</p:attrName>
+                                        </p:attrNameLst>
+                                      </p:cBhvr>
+                                      <p:tavLst>
+                                        <p:tav tm="0">
+                                          <p:val>
+                                            <p:strVal val="#ppt_y+0.04"/>
+                                          </p:val>
+                                        </p:tav>
+                                        <p:tav tm="100000">
+                                          <p:val>
+                                            <p:strVal val="#ppt_y"/>
+                                          </p:val>
+                                        </p:tav>
+                                      </p:tavLst>
+                                    </p:anim>
+                                  </p:childTnLst>
+                                </p:cTn>
+                              </p:par>
+                            </p:childTnLst>
+                          </p:cTn>
+                        </p:par>
+                        <p:par>
+                          <p:cTn id="168" fill="hold">
+                            <p:stCondLst>
+                              <p:cond delay="0"/>
+                            </p:stCondLst>
+                            <p:childTnLst>
+                              <p:par>
+                                <p:cTn id="169" presetID="42" presetClass="entr" presetSubtype="0" fill="hold" grpId="0" nodeType="withEffect">
+                                  <p:stCondLst>
+                                    <p:cond delay="0"/>
+                                  </p:stCondLst>
+                                  <p:childTnLst>
+                                    <p:set>
+                                      <p:cBhvr>
+                                        <p:cTn id="170" dur="1" fill="hold">
+                                          <p:stCondLst>
+                                            <p:cond delay="0"/>
+                                          </p:stCondLst>
+                                        </p:cTn>
+                                        <p:tgtEl>
+                                          <p:spTgt spid="34"/>
+                                        </p:tgtEl>
+                                        <p:attrNameLst>
+                                          <p:attrName>style.visibility</p:attrName>
+                                        </p:attrNameLst>
+                                      </p:cBhvr>
+                                      <p:to>
+                                        <p:strVal val="visible"/>
+                                      </p:to>
+                                    </p:set>
+                                    <p:animEffect transition="in" filter="fade">
+                                      <p:cBhvr>
+                                        <p:cTn id="171" dur="600"/>
+                                        <p:tgtEl>
+                                          <p:spTgt spid="34"/>
+                                        </p:tgtEl>
+                                      </p:cBhvr>
+                                    </p:animEffect>
+                                    <p:anim calcmode="lin" valueType="num">
+                                      <p:cBhvr>
+                                        <p:cTn id="172" dur="600" decel="100000" fill="hold"/>
+                                        <p:tgtEl>
+                                          <p:spTgt spid="34"/>
                                         </p:tgtEl>
                                         <p:attrNameLst>
                                           <p:attrName>ppt_y</p:attrName>
@@ -4503,7 +4812,7 @@
     </p:tnLst>
     <p:bldLst>
       <p:bldP spid="2" grpId="0" animBg="1"/>
-      <p:bldP spid="33" grpId="0" animBg="1"/>
+      <p:bldP spid="36" grpId="0" animBg="1"/>
       <p:bldP spid="4" grpId="0" animBg="1"/>
       <p:bldP spid="5" grpId="0" animBg="1"/>
       <p:bldP spid="7" grpId="0" animBg="1"/>
@@ -4511,22 +4820,24 @@
       <p:bldP spid="9" grpId="0" animBg="1"/>
       <p:bldP spid="10" grpId="0" animBg="1"/>
       <p:bldP spid="11" grpId="0" animBg="1"/>
-      <p:bldP spid="13" grpId="0" animBg="1"/>
+      <p:bldP spid="12" grpId="0" animBg="1"/>
       <p:bldP spid="14" grpId="0" animBg="1"/>
       <p:bldP spid="15" grpId="0" animBg="1"/>
       <p:bldP spid="16" grpId="0" animBg="1"/>
       <p:bldP spid="17" grpId="0" animBg="1"/>
       <p:bldP spid="18" grpId="0" animBg="1"/>
-      <p:bldP spid="20" grpId="0" animBg="1"/>
+      <p:bldP spid="19" grpId="0" animBg="1"/>
       <p:bldP spid="21" grpId="0" animBg="1"/>
       <p:bldP spid="22" grpId="0" animBg="1"/>
       <p:bldP spid="23" grpId="0" animBg="1"/>
       <p:bldP spid="24" grpId="0" animBg="1"/>
       <p:bldP spid="25" grpId="0" animBg="1"/>
       <p:bldP spid="27" grpId="0" animBg="1"/>
-      <p:bldP spid="28" grpId="0" animBg="1"/>
       <p:bldP spid="29" grpId="0" animBg="1"/>
+      <p:bldP spid="30" grpId="0" animBg="1"/>
       <p:bldP spid="31" grpId="0" animBg="1"/>
+      <p:bldP spid="32" grpId="0" animBg="1"/>
+      <p:bldP spid="34" grpId="0" animBg="1"/>
     </p:bldLst>
   </p:timing>
 </p:sld>

</xml_diff>

<commit_message>
Make Workplace Ethics slide text concrete
Co-Authored-By: Claude Opus 5.5 <noreply@anthropic.com>
Claude-Session: https://claude.ai/code/session_01TFmXfwWy7YkFL9ETqt4WJz
</commit_message>
<xml_diff>
--- a/Workplace-Ethics-slide.pptx
+++ b/Workplace-Ethics-slide.pptx
@@ -502,7 +502,7 @@
           <a:p>
             <a:r>
               <a:rPr lang="en-US" dirty="0"/>
-              <a:t>As HR Manager, I'm responsible for how people work together at NutriPill, because for us, how we treat people matters as much as what we sell. Our workplace ethics are based on three ideas. First, respect for everyone: every employee is treated with respect, whatever their gender or race, with no exceptions. Second, living our values: we expect our team to follow our core values, which are innovation, caring for the planet and accessibility. And third, our social responsibility doesn't stop with our employees, it includes our customers too. That's why NutriPill is affordable for all income groups, so that everyone can try it and, as our slogan says, lock in.</a:t>
+              <a:t>As HR Manager, I believe one simple thing: if our team isn't happy, our customers won't be either. So we have three clear rules. First, same job, same pay. Men and women who do the same job earn exactly the same, and we hire people for their skills, never because of their gender or race. Second, everyone has a voice. Once a month, anyone in the company, from the newest worker to the CEO, can pitch an idea to improve NutriPill. That's how we keep innovation alive. And third, nobody is priced out. Our social responsibility includes our customers too, so NutriPill costs just 9.99 a month, and students get 20% off with their student card. That way, anyone can try it and, as our slogan says, lock in.</a:t>
             </a:r>
             <a:endParaRPr lang="en-US" dirty="0"/>
           </a:p>
@@ -1458,7 +1458,7 @@
       </p:sp>
       <p:pic>
         <p:nvPicPr>
-          <p:cNvPr id="6" name="a2_icon" descr="Respect for everyone">    </p:cNvPr>
+          <p:cNvPr id="6" name="a2_icon" descr="Same job, same pay">    </p:cNvPr>
           <p:cNvPicPr>
             <a:picLocks noChangeAspect="1"/>
           </p:cNvPicPr>
@@ -1530,7 +1530,7 @@
                 <a:ea typeface="Calibri" pitchFamily="34" charset="-122"/>
                 <a:cs typeface="Calibri" pitchFamily="34" charset="-120"/>
               </a:rPr>
-              <a:t>Respect for everyone</a:t>
+              <a:t>Same job, same pay</a:t>
             </a:r>
             <a:endParaRPr lang="en-US" sz="1200" dirty="0"/>
           </a:p>
@@ -1569,7 +1569,7 @@
                 <a:ea typeface="Calibri" pitchFamily="34" charset="-122"/>
                 <a:cs typeface="Calibri" pitchFamily="34" charset="-120"/>
               </a:rPr>
-              <a:t>Everyone is treated with respect, whatever their gender or race. No exceptions.</a:t>
+              <a:t>Men and women doing the same job earn the same. We hire for skills, never for gender or race.</a:t>
             </a:r>
             <a:endParaRPr lang="en-US" sz="1400" dirty="0"/>
           </a:p>
@@ -1683,7 +1683,7 @@
       </p:sp>
       <p:pic>
         <p:nvPicPr>
-          <p:cNvPr id="13" name="a3_icon" descr="Living our values">    </p:cNvPr>
+          <p:cNvPr id="13" name="a3_icon" descr="Everyone has a voice">    </p:cNvPr>
           <p:cNvPicPr>
             <a:picLocks noChangeAspect="1"/>
           </p:cNvPicPr>
@@ -1755,7 +1755,7 @@
                 <a:ea typeface="Calibri" pitchFamily="34" charset="-122"/>
                 <a:cs typeface="Calibri" pitchFamily="34" charset="-120"/>
               </a:rPr>
-              <a:t>Living our values</a:t>
+              <a:t>Everyone has a voice</a:t>
             </a:r>
             <a:endParaRPr lang="en-US" sz="1200" dirty="0"/>
           </a:p>
@@ -1794,7 +1794,7 @@
                 <a:ea typeface="Calibri" pitchFamily="34" charset="-122"/>
                 <a:cs typeface="Calibri" pitchFamily="34" charset="-120"/>
               </a:rPr>
-              <a:t>Our team follows our core values: innovation, caring for the planet and accessibility.</a:t>
+              <a:t>Once a month, anyone, from the newest worker to the CEO, can pitch an idea to improve NutriPill.</a:t>
             </a:r>
             <a:endParaRPr lang="en-US" sz="1400" dirty="0"/>
           </a:p>
@@ -1908,7 +1908,7 @@
       </p:sp>
       <p:pic>
         <p:nvPicPr>
-          <p:cNvPr id="20" name="a4_icon" descr="Fair prices for all">    </p:cNvPr>
+          <p:cNvPr id="20" name="a4_icon" descr="Nobody priced out">    </p:cNvPr>
           <p:cNvPicPr>
             <a:picLocks noChangeAspect="1"/>
           </p:cNvPicPr>
@@ -1980,7 +1980,7 @@
                 <a:ea typeface="Calibri" pitchFamily="34" charset="-122"/>
                 <a:cs typeface="Calibri" pitchFamily="34" charset="-120"/>
               </a:rPr>
-              <a:t>Fair prices for all</a:t>
+              <a:t>Nobody priced out</a:t>
             </a:r>
             <a:endParaRPr lang="en-US" sz="1200" dirty="0"/>
           </a:p>
@@ -2019,7 +2019,7 @@
                 <a:ea typeface="Calibri" pitchFamily="34" charset="-122"/>
                 <a:cs typeface="Calibri" pitchFamily="34" charset="-120"/>
               </a:rPr>
-              <a:t>NutriPill is affordable for all income groups, so everyone can try it.</a:t>
+              <a:t>Just €9.99 a month, plus 20% off with a student card, so anyone can try it.</a:t>
             </a:r>
             <a:endParaRPr lang="en-US" sz="1400" dirty="0"/>
           </a:p>
@@ -2159,7 +2159,7 @@
                 <a:ea typeface="Calibri" pitchFamily="34" charset="-122"/>
                 <a:cs typeface="Calibri" pitchFamily="34" charset="-120"/>
               </a:rPr>
-              <a:t>How we treat people matters as much as what we sell.</a:t>
+              <a:t>If our team isn't happy, our customers won't be either.</a:t>
             </a:r>
             <a:endParaRPr lang="en-US" sz="1700" dirty="0"/>
           </a:p>

</xml_diff>

<commit_message>
Improve quote on Workplace Ethics slide
Co-Authored-By: Claude Opus 5.5 <noreply@anthropic.com>
Claude-Session: https://claude.ai/code/session_01TFmXfwWy7YkFL9ETqt4WJz
</commit_message>
<xml_diff>
--- a/Workplace-Ethics-slide.pptx
+++ b/Workplace-Ethics-slide.pptx
@@ -502,7 +502,7 @@
           <a:p>
             <a:r>
               <a:rPr lang="en-US" dirty="0"/>
-              <a:t>As HR Manager, I believe one simple thing: if our team isn't happy, our customers won't be either. So we have three clear rules. First, same job, same pay. Men and women who do the same job earn exactly the same, and we hire people for their skills, never because of their gender or race. Second, everyone has a voice. Once a month, anyone in the company, from the newest worker to the CEO, can pitch an idea to improve NutriPill. That's how we keep innovation alive. And third, nobody is priced out. Our social responsibility includes our customers too, so NutriPill costs just 9.99 a month, and students get 20% off with their student card. That way, anyone can try it and, as our slogan says, lock in.</a:t>
+              <a:t>As HR Manager, I believe one simple thing: take care of your team, and they'll take care of your customers. So we have three clear rules. First, same job, same pay. Men and women who do the same job earn exactly the same, and we hire people for their skills, never because of their gender or race. Second, everyone has a voice. Once a month, anyone in the company, from the newest worker to the CEO, can pitch an idea to improve NutriPill. That's how we keep innovation alive. And third, nobody is priced out. Our social responsibility includes our customers too, so NutriPill costs just 9.99 a month, and students get 20% off with their student card. That way, anyone can try it and, as our slogan says, lock in.</a:t>
             </a:r>
             <a:endParaRPr lang="en-US" dirty="0"/>
           </a:p>
@@ -2134,8 +2134,8 @@
         </p:nvSpPr>
         <p:spPr>
           <a:xfrm>
-            <a:off x="8396935" y="4599432"/>
-            <a:ext cx="3017520" cy="685800"/>
+            <a:off x="8396935" y="4572000"/>
+            <a:ext cx="3108960" cy="640080"/>
           </a:xfrm>
           <a:prstGeom prst="rect">
             <a:avLst/>
@@ -2151,7 +2151,7 @@
               <a:buNone/>
             </a:pPr>
             <a:r>
-              <a:rPr lang="en-US" sz="1700" b="1" dirty="0">
+              <a:rPr lang="en-US" sz="1550" b="1" i="1" dirty="0">
                 <a:solidFill>
                   <a:srgbClr val="0B1F3A"/>
                 </a:solidFill>
@@ -2159,9 +2159,9 @@
                 <a:ea typeface="Calibri" pitchFamily="34" charset="-122"/>
                 <a:cs typeface="Calibri" pitchFamily="34" charset="-120"/>
               </a:rPr>
-              <a:t>If our team isn't happy, our customers won't be either.</a:t>
+              <a:t>Take care of your team, and they'll take care of your customers.</a:t>
             </a:r>
-            <a:endParaRPr lang="en-US" sz="1700" dirty="0"/>
+            <a:endParaRPr lang="en-US" sz="1550" dirty="0"/>
           </a:p>
         </p:txBody>
       </p:sp>

</xml_diff>

<commit_message>
Replace quote with a company promise on Workplace Ethics slide
Co-Authored-By: Claude Opus 5.5 <noreply@anthropic.com>
Claude-Session: https://claude.ai/code/session_01TFmXfwWy7YkFL9ETqt4WJz
</commit_message>
<xml_diff>
--- a/Workplace-Ethics-slide.pptx
+++ b/Workplace-Ethics-slide.pptx
@@ -502,7 +502,7 @@
           <a:p>
             <a:r>
               <a:rPr lang="en-US" dirty="0"/>
-              <a:t>As HR Manager, I believe one simple thing: take care of your team, and they'll take care of your customers. So we have three clear rules. First, same job, same pay. Men and women who do the same job earn exactly the same, and we hire people for their skills, never because of their gender or race. Second, everyone has a voice. Once a month, anyone in the company, from the newest worker to the CEO, can pitch an idea to improve NutriPill. That's how we keep innovation alive. And third, nobody is priced out. Our social responsibility includes our customers too, so NutriPill costs just 9.99 a month, and students get 20% off with their student card. That way, anyone can try it and, as our slogan says, lock in.</a:t>
+              <a:t>As HR Manager, our promise is simple: a happy team means happy customers. So we have three clear rules. First, same job, same pay. Men and women who do the same job earn exactly the same, and we hire people for their skills, never because of their gender or race. Second, everyone has a voice. Once a month, anyone in the company, from the newest worker to the CEO, can pitch an idea to improve NutriPill. That's how we keep innovation alive. And third, nobody is priced out. Our social responsibility includes our customers too, so NutriPill costs just 9.99 a month, and students get 20% off with their student card. That way, anyone can try it and, as our slogan says, lock in.</a:t>
             </a:r>
             <a:endParaRPr lang="en-US" dirty="0"/>
           </a:p>
@@ -2102,40 +2102,16 @@
           </a:effectLst>
         </p:spPr>
       </p:sp>
-      <p:pic>
-        <p:nvPicPr>
-          <p:cNvPr id="26" name="a5_q" descr="/tmp/claude-0/-home-user-english-presentaiton-/38e25695-43d6-5158-a0ef-d97df09ff7da/scratchpad/build/assets/ic-quote-navy.png">    </p:cNvPr>
-          <p:cNvPicPr>
-            <a:picLocks noChangeAspect="1"/>
-          </p:cNvPicPr>
-          <p:nvPr/>
-        </p:nvPicPr>
-        <p:blipFill>
-          <a:blip r:embed="rId5"/>
-          <a:stretch>
-            <a:fillRect/>
-          </a:stretch>
-        </p:blipFill>
-        <p:spPr>
-          <a:xfrm>
-            <a:off x="8396935" y="4206240"/>
-            <a:ext cx="347472" cy="347472"/>
-          </a:xfrm>
-          <a:prstGeom prst="rect">
-            <a:avLst/>
-          </a:prstGeom>
-        </p:spPr>
-      </p:pic>
       <p:sp>
         <p:nvSpPr>
-          <p:cNvPr id="27" name="a5_t"/>
+          <p:cNvPr id="26" name="a5_k"/>
           <p:cNvSpPr txBox="1"/>
           <p:nvPr/>
         </p:nvSpPr>
         <p:spPr>
           <a:xfrm>
-            <a:off x="8396935" y="4572000"/>
-            <a:ext cx="3108960" cy="640080"/>
+            <a:off x="8396935" y="4251960"/>
+            <a:ext cx="2971800" cy="274320"/>
           </a:xfrm>
           <a:prstGeom prst="rect">
             <a:avLst/>
@@ -2151,7 +2127,7 @@
               <a:buNone/>
             </a:pPr>
             <a:r>
-              <a:rPr lang="en-US" sz="1550" b="1" i="1" dirty="0">
+              <a:rPr lang="en-US" sz="1200" b="1" spc="400" kern="0" dirty="0">
                 <a:solidFill>
                   <a:srgbClr val="0B1F3A"/>
                 </a:solidFill>
@@ -2159,9 +2135,48 @@
                 <a:ea typeface="Calibri" pitchFamily="34" charset="-122"/>
                 <a:cs typeface="Calibri" pitchFamily="34" charset="-120"/>
               </a:rPr>
-              <a:t>Take care of your team, and they'll take care of your customers.</a:t>
+              <a:t>OUR PROMISE</a:t>
             </a:r>
-            <a:endParaRPr lang="en-US" sz="1550" dirty="0"/>
+            <a:endParaRPr lang="en-US" sz="1200" dirty="0"/>
+          </a:p>
+        </p:txBody>
+      </p:sp>
+      <p:sp>
+        <p:nvSpPr>
+          <p:cNvPr id="27" name="a5_t"/>
+          <p:cNvSpPr txBox="1"/>
+          <p:nvPr/>
+        </p:nvSpPr>
+        <p:spPr>
+          <a:xfrm>
+            <a:off x="8396935" y="4544568"/>
+            <a:ext cx="3063240" cy="685800"/>
+          </a:xfrm>
+          <a:prstGeom prst="rect">
+            <a:avLst/>
+          </a:prstGeom>
+          <a:noFill/>
+          <a:ln/>
+        </p:spPr>
+        <p:txBody>
+          <a:bodyPr wrap="square" lIns="0" tIns="0" rIns="0" bIns="0" rtlCol="0" anchor="t"/>
+          <a:lstStyle/>
+          <a:p>
+            <a:pPr indent="0" marL="0">
+              <a:buNone/>
+            </a:pPr>
+            <a:r>
+              <a:rPr lang="en-US" sz="2000" b="1" dirty="0">
+                <a:solidFill>
+                  <a:srgbClr val="0B1F3A"/>
+                </a:solidFill>
+                <a:latin typeface="Calibri" pitchFamily="34" charset="0"/>
+                <a:ea typeface="Calibri" pitchFamily="34" charset="-122"/>
+                <a:cs typeface="Calibri" pitchFamily="34" charset="-120"/>
+              </a:rPr>
+              <a:t>A happy team means happy customers.</a:t>
+            </a:r>
+            <a:endParaRPr lang="en-US" sz="2000" dirty="0"/>
           </a:p>
         </p:txBody>
       </p:sp>
@@ -2174,15 +2189,15 @@
           <p:nvPr/>
         </p:nvPicPr>
         <p:blipFill>
-          <a:blip r:embed="rId6"/>
+          <a:blip r:embed="rId5"/>
           <a:stretch>
             <a:fillRect/>
           </a:stretch>
         </p:blipFill>
         <p:spPr>
           <a:xfrm>
-            <a:off x="8342071" y="5257800"/>
-            <a:ext cx="411480" cy="411480"/>
+            <a:off x="8342071" y="5239512"/>
+            <a:ext cx="438912" cy="438912"/>
           </a:xfrm>
           <a:prstGeom prst="rect">
             <a:avLst/>
@@ -2191,14 +2206,14 @@
       </p:pic>
       <p:sp>
         <p:nvSpPr>
-          <p:cNvPr id="29" name="a5_sig"/>
+          <p:cNvPr id="29" name="a5_brand"/>
           <p:cNvSpPr txBox="1"/>
           <p:nvPr/>
         </p:nvSpPr>
         <p:spPr>
           <a:xfrm>
-            <a:off x="8808415" y="5285232"/>
-            <a:ext cx="2377440" cy="365760"/>
+            <a:off x="8808415" y="5276088"/>
+            <a:ext cx="1828800" cy="365760"/>
           </a:xfrm>
           <a:prstGeom prst="rect">
             <a:avLst/>
@@ -2214,7 +2229,7 @@
               <a:buNone/>
             </a:pPr>
             <a:r>
-              <a:rPr lang="en-US" sz="1400" b="1" dirty="0">
+              <a:rPr lang="en-US" sz="1600" b="1" dirty="0">
                 <a:solidFill>
                   <a:srgbClr val="0B1F3A"/>
                 </a:solidFill>
@@ -2222,23 +2237,9 @@
                 <a:ea typeface="Calibri" pitchFamily="34" charset="-122"/>
                 <a:cs typeface="Calibri" pitchFamily="34" charset="-120"/>
               </a:rPr>
-              <a:t>William</a:t>
+              <a:t>NutriPill</a:t>
             </a:r>
-            <a:pPr indent="0" marL="0">
-              <a:buNone/>
-            </a:pPr>
-            <a:r>
-              <a:rPr lang="en-US" sz="1400" dirty="0">
-                <a:solidFill>
-                  <a:srgbClr val="0B1F3A"/>
-                </a:solidFill>
-                <a:latin typeface="Calibri" pitchFamily="34" charset="0"/>
-                <a:ea typeface="Calibri" pitchFamily="34" charset="-122"/>
-                <a:cs typeface="Calibri" pitchFamily="34" charset="-120"/>
-              </a:rPr>
-              <a:t>  ·  HR Manager</a:t>
-            </a:r>
-            <a:endParaRPr lang="en-US" sz="1400" dirty="0"/>
+            <a:endParaRPr lang="en-US" sz="1600" dirty="0"/>
           </a:p>
         </p:txBody>
       </p:sp>
@@ -2326,7 +2327,7 @@
           <p:nvPr/>
         </p:nvPicPr>
         <p:blipFill>
-          <a:blip r:embed="rId7"/>
+          <a:blip r:embed="rId6"/>
           <a:stretch>
             <a:fillRect/>
           </a:stretch>
@@ -4832,6 +4833,7 @@
       <p:bldP spid="23" grpId="0" animBg="1"/>
       <p:bldP spid="24" grpId="0" animBg="1"/>
       <p:bldP spid="25" grpId="0" animBg="1"/>
+      <p:bldP spid="26" grpId="0" animBg="1"/>
       <p:bldP spid="27" grpId="0" animBg="1"/>
       <p:bldP spid="29" grpId="0" animBg="1"/>
       <p:bldP spid="30" grpId="0" animBg="1"/>

</xml_diff>